<commit_message>
mise à jour du cadrage
</commit_message>
<xml_diff>
--- a/cadrage/KWISMO_Presentation - Copie.pptx
+++ b/cadrage/KWISMO_Presentation - Copie.pptx
@@ -5,7 +5,7 @@
     <p:sldMasterId id="2147483648" r:id="rId1"/>
   </p:sldMasterIdLst>
   <p:notesMasterIdLst>
-    <p:notesMasterId r:id="rId30"/>
+    <p:notesMasterId r:id="rId29"/>
   </p:notesMasterIdLst>
   <p:sldIdLst>
     <p:sldId id="256" r:id="rId2"/>
@@ -21,21 +21,20 @@
     <p:sldId id="266" r:id="rId12"/>
     <p:sldId id="267" r:id="rId13"/>
     <p:sldId id="268" r:id="rId14"/>
-    <p:sldId id="283" r:id="rId15"/>
-    <p:sldId id="282" r:id="rId16"/>
-    <p:sldId id="281" r:id="rId17"/>
-    <p:sldId id="269" r:id="rId18"/>
-    <p:sldId id="270" r:id="rId19"/>
-    <p:sldId id="271" r:id="rId20"/>
-    <p:sldId id="272" r:id="rId21"/>
-    <p:sldId id="273" r:id="rId22"/>
-    <p:sldId id="274" r:id="rId23"/>
-    <p:sldId id="275" r:id="rId24"/>
-    <p:sldId id="276" r:id="rId25"/>
-    <p:sldId id="277" r:id="rId26"/>
-    <p:sldId id="278" r:id="rId27"/>
-    <p:sldId id="279" r:id="rId28"/>
-    <p:sldId id="280" r:id="rId29"/>
+    <p:sldId id="282" r:id="rId15"/>
+    <p:sldId id="281" r:id="rId16"/>
+    <p:sldId id="269" r:id="rId17"/>
+    <p:sldId id="270" r:id="rId18"/>
+    <p:sldId id="271" r:id="rId19"/>
+    <p:sldId id="272" r:id="rId20"/>
+    <p:sldId id="273" r:id="rId21"/>
+    <p:sldId id="274" r:id="rId22"/>
+    <p:sldId id="275" r:id="rId23"/>
+    <p:sldId id="276" r:id="rId24"/>
+    <p:sldId id="277" r:id="rId25"/>
+    <p:sldId id="278" r:id="rId26"/>
+    <p:sldId id="279" r:id="rId27"/>
+    <p:sldId id="280" r:id="rId28"/>
   </p:sldIdLst>
   <p:sldSz cx="12192000" cy="6858000"/>
   <p:notesSz cx="6858000" cy="12192000"/>
@@ -692,114 +691,6 @@
         <p:cNvPr id="1" name="">
           <a:extLst>
             <a:ext uri="{FF2B5EF4-FFF2-40B4-BE49-F238E27FC236}">
-              <a16:creationId xmlns:a16="http://schemas.microsoft.com/office/drawing/2014/main" id="{ACC93441-4A50-FC18-B7CD-559B9FE846CA}"/>
-            </a:ext>
-          </a:extLst>
-        </p:cNvPr>
-        <p:cNvGrpSpPr/>
-        <p:nvPr/>
-      </p:nvGrpSpPr>
-      <p:grpSpPr>
-        <a:xfrm>
-          <a:off x="0" y="0"/>
-          <a:ext cx="0" cy="0"/>
-          <a:chOff x="0" y="0"/>
-          <a:chExt cx="0" cy="0"/>
-        </a:xfrm>
-      </p:grpSpPr>
-      <p:sp>
-        <p:nvSpPr>
-          <p:cNvPr id="2" name="Slide Image Placeholder 1">
-            <a:extLst>
-              <a:ext uri="{FF2B5EF4-FFF2-40B4-BE49-F238E27FC236}">
-                <a16:creationId xmlns:a16="http://schemas.microsoft.com/office/drawing/2014/main" id="{700A0932-9895-F782-C5C8-B585FE8693F3}"/>
-              </a:ext>
-            </a:extLst>
-          </p:cNvPr>
-          <p:cNvSpPr>
-            <a:spLocks noGrp="1" noRot="1" noChangeAspect="1"/>
-          </p:cNvSpPr>
-          <p:nvPr>
-            <p:ph type="sldImg"/>
-          </p:nvPr>
-        </p:nvSpPr>
-        <p:spPr/>
-      </p:sp>
-      <p:sp>
-        <p:nvSpPr>
-          <p:cNvPr id="3" name="Notes Placeholder 2">
-            <a:extLst>
-              <a:ext uri="{FF2B5EF4-FFF2-40B4-BE49-F238E27FC236}">
-                <a16:creationId xmlns:a16="http://schemas.microsoft.com/office/drawing/2014/main" id="{6A0FAAB7-C51A-4495-3337-3FEDABE48107}"/>
-              </a:ext>
-            </a:extLst>
-          </p:cNvPr>
-          <p:cNvSpPr>
-            <a:spLocks noGrp="1"/>
-          </p:cNvSpPr>
-          <p:nvPr>
-            <p:ph type="body" idx="1"/>
-          </p:nvPr>
-        </p:nvSpPr>
-        <p:spPr/>
-        <p:txBody>
-          <a:bodyPr/>
-          <a:lstStyle/>
-          <a:p>
-            <a:endParaRPr lang="en-US" dirty="0"/>
-          </a:p>
-        </p:txBody>
-      </p:sp>
-      <p:sp>
-        <p:nvSpPr>
-          <p:cNvPr id="4" name="Slide Number Placeholder 3">
-            <a:extLst>
-              <a:ext uri="{FF2B5EF4-FFF2-40B4-BE49-F238E27FC236}">
-                <a16:creationId xmlns:a16="http://schemas.microsoft.com/office/drawing/2014/main" id="{A6CF18D2-C7C3-43FF-3EF7-B8A60DC80771}"/>
-              </a:ext>
-            </a:extLst>
-          </p:cNvPr>
-          <p:cNvSpPr>
-            <a:spLocks noGrp="1"/>
-          </p:cNvSpPr>
-          <p:nvPr>
-            <p:ph type="sldNum" sz="quarter" idx="10"/>
-          </p:nvPr>
-        </p:nvSpPr>
-        <p:spPr/>
-        <p:txBody>
-          <a:bodyPr/>
-          <a:lstStyle/>
-          <a:p>
-            <a:fld id="{F7021451-1387-4CA6-816F-3879F97B5CBC}" type="slidenum">
-              <a:rPr lang="en-US"/>
-              <a:t>14</a:t>
-            </a:fld>
-            <a:endParaRPr lang="en-US" dirty="0"/>
-          </a:p>
-        </p:txBody>
-      </p:sp>
-    </p:spTree>
-    <p:extLst>
-      <p:ext uri="{BB962C8B-B14F-4D97-AF65-F5344CB8AC3E}">
-        <p14:creationId xmlns:p14="http://schemas.microsoft.com/office/powerpoint/2010/main" val="3739232732"/>
-      </p:ext>
-    </p:extLst>
-  </p:cSld>
-  <p:clrMapOvr>
-    <a:masterClrMapping/>
-  </p:clrMapOvr>
-</p:notes>
-</file>
-
-<file path=ppt/notesSlides/notesSlide15.xml><?xml version="1.0" encoding="utf-8"?>
-<p:notes xmlns:a="http://schemas.openxmlformats.org/drawingml/2006/main" xmlns:r="http://schemas.openxmlformats.org/officeDocument/2006/relationships" xmlns:p="http://schemas.openxmlformats.org/presentationml/2006/main">
-  <p:cSld>
-    <p:spTree>
-      <p:nvGrpSpPr>
-        <p:cNvPr id="1" name="">
-          <a:extLst>
-            <a:ext uri="{FF2B5EF4-FFF2-40B4-BE49-F238E27FC236}">
               <a16:creationId xmlns:a16="http://schemas.microsoft.com/office/drawing/2014/main" id="{96DBB7CF-3D78-4E43-DE87-C958AFD0494D}"/>
             </a:ext>
           </a:extLst>
@@ -881,7 +772,7 @@
           <a:p>
             <a:fld id="{F7021451-1387-4CA6-816F-3879F97B5CBC}" type="slidenum">
               <a:rPr lang="en-US"/>
-              <a:t>15</a:t>
+              <a:t>14</a:t>
             </a:fld>
             <a:endParaRPr lang="en-US" dirty="0"/>
           </a:p>
@@ -900,7 +791,7 @@
 </p:notes>
 </file>
 
-<file path=ppt/notesSlides/notesSlide16.xml><?xml version="1.0" encoding="utf-8"?>
+<file path=ppt/notesSlides/notesSlide15.xml><?xml version="1.0" encoding="utf-8"?>
 <p:notes xmlns:a="http://schemas.openxmlformats.org/drawingml/2006/main" xmlns:r="http://schemas.openxmlformats.org/officeDocument/2006/relationships" xmlns:p="http://schemas.openxmlformats.org/presentationml/2006/main">
   <p:cSld>
     <p:spTree>
@@ -989,7 +880,7 @@
           <a:p>
             <a:fld id="{F7021451-1387-4CA6-816F-3879F97B5CBC}" type="slidenum">
               <a:rPr lang="en-US"/>
-              <a:t>16</a:t>
+              <a:t>15</a:t>
             </a:fld>
             <a:endParaRPr lang="en-US" dirty="0"/>
           </a:p>
@@ -999,6 +890,90 @@
     <p:extLst>
       <p:ext uri="{BB962C8B-B14F-4D97-AF65-F5344CB8AC3E}">
         <p14:creationId xmlns:p14="http://schemas.microsoft.com/office/powerpoint/2010/main" val="538014674"/>
+      </p:ext>
+    </p:extLst>
+  </p:cSld>
+  <p:clrMapOvr>
+    <a:masterClrMapping/>
+  </p:clrMapOvr>
+</p:notes>
+</file>
+
+<file path=ppt/notesSlides/notesSlide16.xml><?xml version="1.0" encoding="utf-8"?>
+<p:notes xmlns:a="http://schemas.openxmlformats.org/drawingml/2006/main" xmlns:r="http://schemas.openxmlformats.org/officeDocument/2006/relationships" xmlns:p="http://schemas.openxmlformats.org/presentationml/2006/main">
+  <p:cSld>
+    <p:spTree>
+      <p:nvGrpSpPr>
+        <p:cNvPr id="1" name=""/>
+        <p:cNvGrpSpPr/>
+        <p:nvPr/>
+      </p:nvGrpSpPr>
+      <p:grpSpPr>
+        <a:xfrm>
+          <a:off x="0" y="0"/>
+          <a:ext cx="0" cy="0"/>
+          <a:chOff x="0" y="0"/>
+          <a:chExt cx="0" cy="0"/>
+        </a:xfrm>
+      </p:grpSpPr>
+      <p:sp>
+        <p:nvSpPr>
+          <p:cNvPr id="2" name="Slide Image Placeholder 1"/>
+          <p:cNvSpPr>
+            <a:spLocks noGrp="1" noRot="1" noChangeAspect="1"/>
+          </p:cNvSpPr>
+          <p:nvPr>
+            <p:ph type="sldImg"/>
+          </p:nvPr>
+        </p:nvSpPr>
+        <p:spPr/>
+      </p:sp>
+      <p:sp>
+        <p:nvSpPr>
+          <p:cNvPr id="3" name="Notes Placeholder 2"/>
+          <p:cNvSpPr>
+            <a:spLocks noGrp="1"/>
+          </p:cNvSpPr>
+          <p:nvPr>
+            <p:ph type="body" idx="1"/>
+          </p:nvPr>
+        </p:nvSpPr>
+        <p:spPr/>
+        <p:txBody>
+          <a:bodyPr/>
+          <a:lstStyle/>
+          <a:p>
+            <a:endParaRPr lang="en-US" dirty="0"/>
+          </a:p>
+        </p:txBody>
+      </p:sp>
+      <p:sp>
+        <p:nvSpPr>
+          <p:cNvPr id="4" name="Slide Number Placeholder 3"/>
+          <p:cNvSpPr>
+            <a:spLocks noGrp="1"/>
+          </p:cNvSpPr>
+          <p:nvPr>
+            <p:ph type="sldNum" sz="quarter" idx="10"/>
+          </p:nvPr>
+        </p:nvSpPr>
+        <p:spPr/>
+        <p:txBody>
+          <a:bodyPr/>
+          <a:lstStyle/>
+          <a:p>
+            <a:fld id="{F7021451-1387-4CA6-816F-3879F97B5CBC}" type="slidenum">
+              <a:rPr lang="en-US"/>
+              <a:t>16</a:t>
+            </a:fld>
+            <a:endParaRPr lang="en-US"/>
+          </a:p>
+        </p:txBody>
+      </p:sp>
+    </p:spTree>
+    <p:extLst>
+      <p:ext uri="{BB962C8B-B14F-4D97-AF65-F5344CB8AC3E}">
+        <p14:creationId xmlns:p14="http://schemas.microsoft.com/office/powerpoint/2010/main" val="1024086991"/>
       </p:ext>
     </p:extLst>
   </p:cSld>
@@ -1937,90 +1912,6 @@
   <p:cSld>
     <p:spTree>
       <p:nvGrpSpPr>
-        <p:cNvPr id="1" name=""/>
-        <p:cNvGrpSpPr/>
-        <p:nvPr/>
-      </p:nvGrpSpPr>
-      <p:grpSpPr>
-        <a:xfrm>
-          <a:off x="0" y="0"/>
-          <a:ext cx="0" cy="0"/>
-          <a:chOff x="0" y="0"/>
-          <a:chExt cx="0" cy="0"/>
-        </a:xfrm>
-      </p:grpSpPr>
-      <p:sp>
-        <p:nvSpPr>
-          <p:cNvPr id="2" name="Slide Image Placeholder 1"/>
-          <p:cNvSpPr>
-            <a:spLocks noGrp="1" noRot="1" noChangeAspect="1"/>
-          </p:cNvSpPr>
-          <p:nvPr>
-            <p:ph type="sldImg"/>
-          </p:nvPr>
-        </p:nvSpPr>
-        <p:spPr/>
-      </p:sp>
-      <p:sp>
-        <p:nvSpPr>
-          <p:cNvPr id="3" name="Notes Placeholder 2"/>
-          <p:cNvSpPr>
-            <a:spLocks noGrp="1"/>
-          </p:cNvSpPr>
-          <p:nvPr>
-            <p:ph type="body" idx="1"/>
-          </p:nvPr>
-        </p:nvSpPr>
-        <p:spPr/>
-        <p:txBody>
-          <a:bodyPr/>
-          <a:lstStyle/>
-          <a:p>
-            <a:endParaRPr lang="en-US" dirty="0"/>
-          </a:p>
-        </p:txBody>
-      </p:sp>
-      <p:sp>
-        <p:nvSpPr>
-          <p:cNvPr id="4" name="Slide Number Placeholder 3"/>
-          <p:cNvSpPr>
-            <a:spLocks noGrp="1"/>
-          </p:cNvSpPr>
-          <p:nvPr>
-            <p:ph type="sldNum" sz="quarter" idx="10"/>
-          </p:nvPr>
-        </p:nvSpPr>
-        <p:spPr/>
-        <p:txBody>
-          <a:bodyPr/>
-          <a:lstStyle/>
-          <a:p>
-            <a:fld id="{F7021451-1387-4CA6-816F-3879F97B5CBC}" type="slidenum">
-              <a:rPr lang="en-US"/>
-              <a:t>27</a:t>
-            </a:fld>
-            <a:endParaRPr lang="en-US"/>
-          </a:p>
-        </p:txBody>
-      </p:sp>
-    </p:spTree>
-    <p:extLst>
-      <p:ext uri="{BB962C8B-B14F-4D97-AF65-F5344CB8AC3E}">
-        <p14:creationId xmlns:p14="http://schemas.microsoft.com/office/powerpoint/2010/main" val="1024086991"/>
-      </p:ext>
-    </p:extLst>
-  </p:cSld>
-  <p:clrMapOvr>
-    <a:masterClrMapping/>
-  </p:clrMapOvr>
-</p:notes>
-</file>
-
-<file path=ppt/notesSlides/notesSlide28.xml><?xml version="1.0" encoding="utf-8"?>
-<p:notes xmlns:a="http://schemas.openxmlformats.org/drawingml/2006/main" xmlns:r="http://schemas.openxmlformats.org/officeDocument/2006/relationships" xmlns:p="http://schemas.openxmlformats.org/presentationml/2006/main">
-  <p:cSld>
-    <p:spTree>
-      <p:nvGrpSpPr>
         <p:cNvPr id="1" name="">
           <a:extLst>
             <a:ext uri="{FF2B5EF4-FFF2-40B4-BE49-F238E27FC236}">
@@ -2105,7 +1996,7 @@
           <a:p>
             <a:fld id="{F7021451-1387-4CA6-816F-3879F97B5CBC}" type="slidenum">
               <a:rPr lang="en-US"/>
-              <a:t>28</a:t>
+              <a:t>27</a:t>
             </a:fld>
             <a:endParaRPr lang="en-US" dirty="0"/>
           </a:p>
@@ -5881,14 +5772,13 @@
         </p:nvPicPr>
         <p:blipFill>
           <a:blip r:embed="rId4"/>
-          <a:stretch>
-            <a:fillRect/>
-          </a:stretch>
+          <a:srcRect/>
+          <a:stretch/>
         </p:blipFill>
         <p:spPr>
           <a:xfrm>
             <a:off x="502920" y="1327104"/>
-            <a:ext cx="9279999" cy="5220000"/>
+            <a:ext cx="9279999" cy="5219999"/>
           </a:xfrm>
           <a:prstGeom prst="rect">
             <a:avLst/>
@@ -5904,267 +5794,6 @@
 </file>
 
 <file path=ppt/slides/slide14.xml><?xml version="1.0" encoding="utf-8"?>
-<p:sld xmlns:a="http://schemas.openxmlformats.org/drawingml/2006/main" xmlns:r="http://schemas.openxmlformats.org/officeDocument/2006/relationships" xmlns:p="http://schemas.openxmlformats.org/presentationml/2006/main">
-  <p:cSld>
-    <p:bg>
-      <p:bgPr>
-        <a:solidFill>
-          <a:srgbClr val="1B2333"/>
-        </a:solidFill>
-        <a:effectLst/>
-      </p:bgPr>
-    </p:bg>
-    <p:spTree>
-      <p:nvGrpSpPr>
-        <p:cNvPr id="1" name="">
-          <a:extLst>
-            <a:ext uri="{FF2B5EF4-FFF2-40B4-BE49-F238E27FC236}">
-              <a16:creationId xmlns:a16="http://schemas.microsoft.com/office/drawing/2014/main" id="{064B5B40-56FA-D487-7213-38F5830ABE35}"/>
-            </a:ext>
-          </a:extLst>
-        </p:cNvPr>
-        <p:cNvGrpSpPr/>
-        <p:nvPr/>
-      </p:nvGrpSpPr>
-      <p:grpSpPr>
-        <a:xfrm>
-          <a:off x="0" y="0"/>
-          <a:ext cx="0" cy="0"/>
-          <a:chOff x="0" y="0"/>
-          <a:chExt cx="0" cy="0"/>
-        </a:xfrm>
-      </p:grpSpPr>
-      <p:pic>
-        <p:nvPicPr>
-          <p:cNvPr id="40" name="Image 0" descr="/home/claude/work/bg/bg_content.png">
-            <a:extLst>
-              <a:ext uri="{FF2B5EF4-FFF2-40B4-BE49-F238E27FC236}">
-                <a16:creationId xmlns:a16="http://schemas.microsoft.com/office/drawing/2014/main" id="{182BDDD3-401A-C4B5-8D92-CBE020665893}"/>
-              </a:ext>
-            </a:extLst>
-          </p:cNvPr>
-          <p:cNvPicPr>
-            <a:picLocks noChangeAspect="1"/>
-          </p:cNvPicPr>
-          <p:nvPr/>
-        </p:nvPicPr>
-        <p:blipFill>
-          <a:blip r:embed="rId3"/>
-          <a:stretch>
-            <a:fillRect/>
-          </a:stretch>
-        </p:blipFill>
-        <p:spPr>
-          <a:xfrm>
-            <a:off x="0" y="0"/>
-            <a:ext cx="12191695" cy="6858000"/>
-          </a:xfrm>
-          <a:prstGeom prst="rect">
-            <a:avLst/>
-          </a:prstGeom>
-        </p:spPr>
-      </p:pic>
-      <p:sp>
-        <p:nvSpPr>
-          <p:cNvPr id="3" name="Text 0">
-            <a:extLst>
-              <a:ext uri="{FF2B5EF4-FFF2-40B4-BE49-F238E27FC236}">
-                <a16:creationId xmlns:a16="http://schemas.microsoft.com/office/drawing/2014/main" id="{DC691BD3-46FE-9645-EF65-A0C6228B0D8D}"/>
-              </a:ext>
-            </a:extLst>
-          </p:cNvPr>
-          <p:cNvSpPr/>
-          <p:nvPr/>
-        </p:nvSpPr>
-        <p:spPr>
-          <a:xfrm>
-            <a:off x="502920" y="384048"/>
-            <a:ext cx="9144000" cy="310896"/>
-          </a:xfrm>
-          <a:prstGeom prst="rect">
-            <a:avLst/>
-          </a:prstGeom>
-          <a:noFill/>
-          <a:ln/>
-        </p:spPr>
-        <p:txBody>
-          <a:bodyPr wrap="square" lIns="0" tIns="0" rIns="0" bIns="0" rtlCol="0" anchor="ctr"/>
-          <a:lstStyle/>
-          <a:p>
-            <a:pPr marL="0" indent="0">
-              <a:buNone/>
-            </a:pPr>
-            <a:r>
-              <a:rPr lang="en-US" sz="1300" b="1" kern="0" spc="200" dirty="0">
-                <a:solidFill>
-                  <a:srgbClr val="FF7900"/>
-                </a:solidFill>
-                <a:latin typeface="Calibri" pitchFamily="34" charset="0"/>
-                <a:ea typeface="Calibri" pitchFamily="34" charset="-122"/>
-                <a:cs typeface="Calibri" pitchFamily="34" charset="-120"/>
-              </a:rPr>
-              <a:t>PERSONAS</a:t>
-            </a:r>
-            <a:endParaRPr lang="en-US" sz="1300" dirty="0"/>
-          </a:p>
-        </p:txBody>
-      </p:sp>
-      <p:sp>
-        <p:nvSpPr>
-          <p:cNvPr id="4" name="Text 1">
-            <a:extLst>
-              <a:ext uri="{FF2B5EF4-FFF2-40B4-BE49-F238E27FC236}">
-                <a16:creationId xmlns:a16="http://schemas.microsoft.com/office/drawing/2014/main" id="{5CAC12CE-A145-D035-8272-B4C11711C3DA}"/>
-              </a:ext>
-            </a:extLst>
-          </p:cNvPr>
-          <p:cNvSpPr/>
-          <p:nvPr/>
-        </p:nvSpPr>
-        <p:spPr>
-          <a:xfrm>
-            <a:off x="502920" y="658368"/>
-            <a:ext cx="10607040" cy="685800"/>
-          </a:xfrm>
-          <a:prstGeom prst="rect">
-            <a:avLst/>
-          </a:prstGeom>
-          <a:noFill/>
-          <a:ln/>
-        </p:spPr>
-        <p:txBody>
-          <a:bodyPr wrap="square" lIns="0" tIns="0" rIns="0" bIns="0" rtlCol="0" anchor="ctr"/>
-          <a:lstStyle/>
-          <a:p>
-            <a:pPr marL="0" indent="0">
-              <a:buNone/>
-            </a:pPr>
-            <a:r>
-              <a:rPr lang="fr-FR" sz="2800" b="1" dirty="0">
-                <a:solidFill>
-                  <a:srgbClr val="FFFFFF"/>
-                </a:solidFill>
-                <a:latin typeface="Montserrat" pitchFamily="34" charset="0"/>
-                <a:ea typeface="Montserrat" pitchFamily="34" charset="-122"/>
-                <a:cs typeface="Montserrat" pitchFamily="34" charset="-120"/>
-              </a:rPr>
-              <a:t>2</a:t>
-            </a:r>
-            <a:r>
-              <a:rPr lang="fr-FR" sz="2800" b="1" noProof="0" dirty="0" err="1">
-                <a:solidFill>
-                  <a:srgbClr val="FFFFFF"/>
-                </a:solidFill>
-                <a:latin typeface="Montserrat" pitchFamily="34" charset="0"/>
-                <a:ea typeface="Montserrat" pitchFamily="34" charset="-122"/>
-                <a:cs typeface="Montserrat" pitchFamily="34" charset="-120"/>
-              </a:rPr>
-              <a:t>ème</a:t>
-            </a:r>
-            <a:r>
-              <a:rPr lang="fr-FR" sz="2800" b="1" noProof="0" dirty="0">
-                <a:solidFill>
-                  <a:srgbClr val="FFFFFF"/>
-                </a:solidFill>
-                <a:latin typeface="Montserrat" pitchFamily="34" charset="0"/>
-                <a:ea typeface="Montserrat" pitchFamily="34" charset="-122"/>
-                <a:cs typeface="Montserrat" pitchFamily="34" charset="-120"/>
-              </a:rPr>
-              <a:t> situation réelle de fraude</a:t>
-            </a:r>
-            <a:endParaRPr lang="fr-FR" sz="2800" noProof="0" dirty="0"/>
-          </a:p>
-        </p:txBody>
-      </p:sp>
-      <p:sp>
-        <p:nvSpPr>
-          <p:cNvPr id="38" name="Text 32">
-            <a:extLst>
-              <a:ext uri="{FF2B5EF4-FFF2-40B4-BE49-F238E27FC236}">
-                <a16:creationId xmlns:a16="http://schemas.microsoft.com/office/drawing/2014/main" id="{0F063FEE-F9E6-A539-2713-0565D6B9A687}"/>
-              </a:ext>
-            </a:extLst>
-          </p:cNvPr>
-          <p:cNvSpPr/>
-          <p:nvPr/>
-        </p:nvSpPr>
-        <p:spPr>
-          <a:xfrm>
-            <a:off x="11368735" y="6400800"/>
-            <a:ext cx="548640" cy="292608"/>
-          </a:xfrm>
-          <a:prstGeom prst="rect">
-            <a:avLst/>
-          </a:prstGeom>
-          <a:noFill/>
-          <a:ln/>
-        </p:spPr>
-        <p:txBody>
-          <a:bodyPr wrap="square" lIns="0" tIns="0" rIns="0" bIns="0" rtlCol="0" anchor="ctr"/>
-          <a:lstStyle/>
-          <a:p>
-            <a:pPr marL="0" indent="0" algn="r">
-              <a:buNone/>
-            </a:pPr>
-            <a:r>
-              <a:rPr lang="en-US" sz="1100" dirty="0">
-                <a:solidFill>
-                  <a:srgbClr val="8891A3"/>
-                </a:solidFill>
-                <a:latin typeface="Calibri" pitchFamily="34" charset="0"/>
-                <a:ea typeface="Calibri" pitchFamily="34" charset="-122"/>
-                <a:cs typeface="Calibri" pitchFamily="34" charset="-120"/>
-              </a:rPr>
-              <a:t>14</a:t>
-            </a:r>
-            <a:endParaRPr lang="en-US" sz="1100" dirty="0"/>
-          </a:p>
-        </p:txBody>
-      </p:sp>
-      <p:pic>
-        <p:nvPicPr>
-          <p:cNvPr id="5" name="Image 4">
-            <a:extLst>
-              <a:ext uri="{FF2B5EF4-FFF2-40B4-BE49-F238E27FC236}">
-                <a16:creationId xmlns:a16="http://schemas.microsoft.com/office/drawing/2014/main" id="{A4B872D9-D05C-8F8D-93B8-861A2A6D2CEE}"/>
-              </a:ext>
-            </a:extLst>
-          </p:cNvPr>
-          <p:cNvPicPr>
-            <a:picLocks noChangeAspect="1"/>
-          </p:cNvPicPr>
-          <p:nvPr/>
-        </p:nvPicPr>
-        <p:blipFill>
-          <a:blip r:embed="rId4"/>
-          <a:stretch>
-            <a:fillRect/>
-          </a:stretch>
-        </p:blipFill>
-        <p:spPr>
-          <a:xfrm>
-            <a:off x="502920" y="1327104"/>
-            <a:ext cx="9280000" cy="5220000"/>
-          </a:xfrm>
-          <a:prstGeom prst="rect">
-            <a:avLst/>
-          </a:prstGeom>
-        </p:spPr>
-      </p:pic>
-    </p:spTree>
-    <p:extLst>
-      <p:ext uri="{BB962C8B-B14F-4D97-AF65-F5344CB8AC3E}">
-        <p14:creationId xmlns:p14="http://schemas.microsoft.com/office/powerpoint/2010/main" val="3462195490"/>
-      </p:ext>
-    </p:extLst>
-  </p:cSld>
-  <p:clrMapOvr>
-    <a:masterClrMapping/>
-  </p:clrMapOvr>
-</p:sld>
-</file>
-
-<file path=ppt/slides/slide15.xml><?xml version="1.0" encoding="utf-8"?>
 <p:sld xmlns:a="http://schemas.openxmlformats.org/drawingml/2006/main" xmlns:r="http://schemas.openxmlformats.org/officeDocument/2006/relationships" xmlns:p="http://schemas.openxmlformats.org/presentationml/2006/main">
   <p:cSld>
     <p:bg>
@@ -6306,7 +5935,7 @@
                 <a:ea typeface="Montserrat" pitchFamily="34" charset="-122"/>
                 <a:cs typeface="Montserrat" pitchFamily="34" charset="-120"/>
               </a:rPr>
-              <a:t>3ème</a:t>
+              <a:t>2ème</a:t>
             </a:r>
             <a:r>
               <a:rPr lang="fr-FR" sz="2800" b="1" noProof="0" dirty="0">
@@ -6362,7 +5991,7 @@
                 <a:ea typeface="Calibri" pitchFamily="34" charset="-122"/>
                 <a:cs typeface="Calibri" pitchFamily="34" charset="-120"/>
               </a:rPr>
-              <a:t>15</a:t>
+              <a:t>14</a:t>
             </a:r>
             <a:endParaRPr lang="en-US" sz="1100" dirty="0"/>
           </a:p>
@@ -6384,14 +6013,13 @@
         </p:nvPicPr>
         <p:blipFill>
           <a:blip r:embed="rId4"/>
-          <a:stretch>
-            <a:fillRect/>
-          </a:stretch>
+          <a:srcRect/>
+          <a:stretch/>
         </p:blipFill>
         <p:spPr>
           <a:xfrm>
             <a:off x="502920" y="1327104"/>
-            <a:ext cx="9280000" cy="5220000"/>
+            <a:ext cx="9280000" cy="5219999"/>
           </a:xfrm>
           <a:prstGeom prst="rect">
             <a:avLst/>
@@ -6411,7 +6039,7 @@
 </p:sld>
 </file>
 
-<file path=ppt/slides/slide16.xml><?xml version="1.0" encoding="utf-8"?>
+<file path=ppt/slides/slide15.xml><?xml version="1.0" encoding="utf-8"?>
 <p:sld xmlns:a="http://schemas.openxmlformats.org/drawingml/2006/main" xmlns:r="http://schemas.openxmlformats.org/officeDocument/2006/relationships" xmlns:p="http://schemas.openxmlformats.org/presentationml/2006/main">
   <p:cSld>
     <p:bg>
@@ -6553,7 +6181,7 @@
                 <a:ea typeface="Montserrat" pitchFamily="34" charset="-122"/>
                 <a:cs typeface="Montserrat" pitchFamily="34" charset="-120"/>
               </a:rPr>
-              <a:t>4ème</a:t>
+              <a:t>3ème</a:t>
             </a:r>
             <a:r>
               <a:rPr lang="fr-FR" sz="2800" b="1" noProof="0" dirty="0">
@@ -6609,7 +6237,7 @@
                 <a:ea typeface="Calibri" pitchFamily="34" charset="-122"/>
                 <a:cs typeface="Calibri" pitchFamily="34" charset="-120"/>
               </a:rPr>
-              <a:t>16</a:t>
+              <a:t>15</a:t>
             </a:r>
             <a:endParaRPr lang="en-US" sz="1100" dirty="0"/>
           </a:p>
@@ -6631,14 +6259,13 @@
         </p:nvPicPr>
         <p:blipFill>
           <a:blip r:embed="rId4"/>
-          <a:stretch>
-            <a:fillRect/>
-          </a:stretch>
+          <a:srcRect/>
+          <a:stretch/>
         </p:blipFill>
         <p:spPr>
           <a:xfrm>
             <a:off x="502920" y="1327104"/>
-            <a:ext cx="9280000" cy="5220000"/>
+            <a:ext cx="9280000" cy="5219999"/>
           </a:xfrm>
           <a:prstGeom prst="rect">
             <a:avLst/>
@@ -6658,7 +6285,7 @@
 </p:sld>
 </file>
 
-<file path=ppt/slides/slide17.xml><?xml version="1.0" encoding="utf-8"?>
+<file path=ppt/slides/slide16.xml><?xml version="1.0" encoding="utf-8"?>
 <p:sld xmlns:a="http://schemas.openxmlformats.org/drawingml/2006/main" xmlns:r="http://schemas.openxmlformats.org/officeDocument/2006/relationships" xmlns:p="http://schemas.openxmlformats.org/presentationml/2006/main">
   <p:cSld name="Slide 14">
     <p:bg>
@@ -7020,7 +6647,7 @@
                 <a:ea typeface="Calibri" pitchFamily="34" charset="-122"/>
                 <a:cs typeface="Calibri" pitchFamily="34" charset="-120"/>
               </a:rPr>
-              <a:t>17</a:t>
+              <a:t>16</a:t>
             </a:r>
             <a:endParaRPr lang="en-US" sz="1100" dirty="0"/>
           </a:p>
@@ -7034,7 +6661,7 @@
 </p:sld>
 </file>
 
-<file path=ppt/slides/slide18.xml><?xml version="1.0" encoding="utf-8"?>
+<file path=ppt/slides/slide17.xml><?xml version="1.0" encoding="utf-8"?>
 <p:sld xmlns:a="http://schemas.openxmlformats.org/drawingml/2006/main" xmlns:r="http://schemas.openxmlformats.org/officeDocument/2006/relationships" xmlns:p="http://schemas.openxmlformats.org/presentationml/2006/main">
   <p:cSld name="Slide 15">
     <p:bg>
@@ -7693,7 +7320,7 @@
                 <a:ea typeface="Calibri" pitchFamily="34" charset="-122"/>
                 <a:cs typeface="Calibri" pitchFamily="34" charset="-120"/>
               </a:rPr>
-              <a:t>18</a:t>
+              <a:t>17</a:t>
             </a:r>
             <a:endParaRPr lang="en-US" sz="1100" dirty="0"/>
           </a:p>
@@ -7707,7 +7334,7 @@
 </p:sld>
 </file>
 
-<file path=ppt/slides/slide19.xml><?xml version="1.0" encoding="utf-8"?>
+<file path=ppt/slides/slide18.xml><?xml version="1.0" encoding="utf-8"?>
 <p:sld xmlns:a="http://schemas.openxmlformats.org/drawingml/2006/main" xmlns:r="http://schemas.openxmlformats.org/officeDocument/2006/relationships" xmlns:p="http://schemas.openxmlformats.org/presentationml/2006/main">
   <p:cSld name="Slide 16">
     <p:bg>
@@ -8823,6 +8450,402 @@
       <p:sp>
         <p:nvSpPr>
           <p:cNvPr id="35" name="Text 27"/>
+          <p:cNvSpPr/>
+          <p:nvPr/>
+        </p:nvSpPr>
+        <p:spPr>
+          <a:xfrm>
+            <a:off x="11368735" y="6400800"/>
+            <a:ext cx="548640" cy="292608"/>
+          </a:xfrm>
+          <a:prstGeom prst="rect">
+            <a:avLst/>
+          </a:prstGeom>
+          <a:noFill/>
+          <a:ln/>
+        </p:spPr>
+        <p:txBody>
+          <a:bodyPr wrap="square" lIns="0" tIns="0" rIns="0" bIns="0" rtlCol="0" anchor="ctr"/>
+          <a:lstStyle/>
+          <a:p>
+            <a:pPr marL="0" indent="0" algn="r">
+              <a:buNone/>
+            </a:pPr>
+            <a:r>
+              <a:rPr lang="en-US" sz="1100" dirty="0">
+                <a:solidFill>
+                  <a:srgbClr val="8891A3"/>
+                </a:solidFill>
+                <a:latin typeface="Calibri" pitchFamily="34" charset="0"/>
+                <a:ea typeface="Calibri" pitchFamily="34" charset="-122"/>
+                <a:cs typeface="Calibri" pitchFamily="34" charset="-120"/>
+              </a:rPr>
+              <a:t>18</a:t>
+            </a:r>
+            <a:endParaRPr lang="en-US" sz="1100" dirty="0"/>
+          </a:p>
+        </p:txBody>
+      </p:sp>
+    </p:spTree>
+  </p:cSld>
+  <p:clrMapOvr>
+    <a:masterClrMapping/>
+  </p:clrMapOvr>
+</p:sld>
+</file>
+
+<file path=ppt/slides/slide19.xml><?xml version="1.0" encoding="utf-8"?>
+<p:sld xmlns:a="http://schemas.openxmlformats.org/drawingml/2006/main" xmlns:r="http://schemas.openxmlformats.org/officeDocument/2006/relationships" xmlns:p="http://schemas.openxmlformats.org/presentationml/2006/main">
+  <p:cSld name="Slide 17">
+    <p:bg>
+      <p:bgPr>
+        <a:solidFill>
+          <a:srgbClr val="1B2333"/>
+        </a:solidFill>
+        <a:effectLst/>
+      </p:bgPr>
+    </p:bg>
+    <p:spTree>
+      <p:nvGrpSpPr>
+        <p:cNvPr id="1" name=""/>
+        <p:cNvGrpSpPr/>
+        <p:nvPr/>
+      </p:nvGrpSpPr>
+      <p:grpSpPr>
+        <a:xfrm>
+          <a:off x="0" y="0"/>
+          <a:ext cx="0" cy="0"/>
+          <a:chOff x="0" y="0"/>
+          <a:chExt cx="0" cy="0"/>
+        </a:xfrm>
+      </p:grpSpPr>
+      <p:pic>
+        <p:nvPicPr>
+          <p:cNvPr id="2" name="Image 0" descr="/home/claude/work/bg/bg_divider.png"/>
+          <p:cNvPicPr>
+            <a:picLocks noChangeAspect="1"/>
+          </p:cNvPicPr>
+          <p:nvPr/>
+        </p:nvPicPr>
+        <p:blipFill>
+          <a:blip r:embed="rId3"/>
+          <a:stretch>
+            <a:fillRect/>
+          </a:stretch>
+        </p:blipFill>
+        <p:spPr>
+          <a:xfrm>
+            <a:off x="0" y="0"/>
+            <a:ext cx="12191695" cy="6858000"/>
+          </a:xfrm>
+          <a:prstGeom prst="rect">
+            <a:avLst/>
+          </a:prstGeom>
+        </p:spPr>
+      </p:pic>
+      <p:sp>
+        <p:nvSpPr>
+          <p:cNvPr id="3" name="Text 0"/>
+          <p:cNvSpPr/>
+          <p:nvPr/>
+        </p:nvSpPr>
+        <p:spPr>
+          <a:xfrm>
+            <a:off x="731520" y="1051560"/>
+            <a:ext cx="5486400" cy="320040"/>
+          </a:xfrm>
+          <a:prstGeom prst="rect">
+            <a:avLst/>
+          </a:prstGeom>
+          <a:noFill/>
+          <a:ln/>
+        </p:spPr>
+        <p:txBody>
+          <a:bodyPr wrap="square" lIns="0" tIns="0" rIns="0" bIns="0" rtlCol="0" anchor="ctr"/>
+          <a:lstStyle/>
+          <a:p>
+            <a:pPr marL="0" indent="0">
+              <a:buNone/>
+            </a:pPr>
+            <a:r>
+              <a:rPr lang="en-US" sz="1300" b="1" kern="0" spc="200" dirty="0">
+                <a:solidFill>
+                  <a:srgbClr val="4D6AB1"/>
+                </a:solidFill>
+                <a:latin typeface="Calibri" pitchFamily="34" charset="0"/>
+                <a:ea typeface="Calibri" pitchFamily="34" charset="-122"/>
+                <a:cs typeface="Calibri" pitchFamily="34" charset="-120"/>
+              </a:rPr>
+              <a:t>SECTION 07 / 09</a:t>
+            </a:r>
+            <a:endParaRPr lang="en-US" sz="1300" dirty="0"/>
+          </a:p>
+        </p:txBody>
+      </p:sp>
+      <p:sp>
+        <p:nvSpPr>
+          <p:cNvPr id="4" name="Text 1"/>
+          <p:cNvSpPr/>
+          <p:nvPr/>
+        </p:nvSpPr>
+        <p:spPr>
+          <a:xfrm>
+            <a:off x="731520" y="1417320"/>
+            <a:ext cx="6858000" cy="457200"/>
+          </a:xfrm>
+          <a:prstGeom prst="rect">
+            <a:avLst/>
+          </a:prstGeom>
+          <a:noFill/>
+          <a:ln/>
+        </p:spPr>
+        <p:txBody>
+          <a:bodyPr wrap="square" lIns="0" tIns="0" rIns="0" bIns="0" rtlCol="0" anchor="ctr"/>
+          <a:lstStyle/>
+          <a:p>
+            <a:pPr marL="0" indent="0">
+              <a:buNone/>
+            </a:pPr>
+            <a:r>
+              <a:rPr lang="en-US" sz="1500" b="1" kern="0" spc="150" dirty="0">
+                <a:solidFill>
+                  <a:srgbClr val="C9CEDA"/>
+                </a:solidFill>
+                <a:latin typeface="Calibri" pitchFamily="34" charset="0"/>
+                <a:ea typeface="Calibri" pitchFamily="34" charset="-122"/>
+                <a:cs typeface="Calibri" pitchFamily="34" charset="-120"/>
+              </a:rPr>
+              <a:t>SE DIFFÉRENCIER</a:t>
+            </a:r>
+            <a:endParaRPr lang="en-US" sz="1500" dirty="0"/>
+          </a:p>
+        </p:txBody>
+      </p:sp>
+      <p:sp>
+        <p:nvSpPr>
+          <p:cNvPr id="5" name="Text 2"/>
+          <p:cNvSpPr/>
+          <p:nvPr/>
+        </p:nvSpPr>
+        <p:spPr>
+          <a:xfrm>
+            <a:off x="731520" y="2468880"/>
+            <a:ext cx="6949440" cy="1920240"/>
+          </a:xfrm>
+          <a:prstGeom prst="rect">
+            <a:avLst/>
+          </a:prstGeom>
+          <a:noFill/>
+          <a:ln/>
+        </p:spPr>
+        <p:txBody>
+          <a:bodyPr wrap="square" lIns="0" tIns="0" rIns="0" bIns="0" rtlCol="0" anchor="ctr"/>
+          <a:lstStyle/>
+          <a:p>
+            <a:pPr marL="0" indent="0">
+              <a:lnSpc>
+                <a:spcPct val="105000"/>
+              </a:lnSpc>
+              <a:buNone/>
+            </a:pPr>
+            <a:r>
+              <a:rPr lang="en-US" sz="4600" b="1" dirty="0">
+                <a:solidFill>
+                  <a:srgbClr val="FFFFFF"/>
+                </a:solidFill>
+                <a:latin typeface="Montserrat" pitchFamily="34" charset="0"/>
+                <a:ea typeface="Montserrat" pitchFamily="34" charset="-122"/>
+                <a:cs typeface="Montserrat" pitchFamily="34" charset="-120"/>
+              </a:rPr>
+              <a:t>Positionnement &amp;</a:t>
+            </a:r>
+            <a:endParaRPr lang="en-US" sz="4600" dirty="0"/>
+          </a:p>
+          <a:p>
+            <a:pPr marL="0" indent="0">
+              <a:lnSpc>
+                <a:spcPct val="105000"/>
+              </a:lnSpc>
+              <a:buNone/>
+            </a:pPr>
+            <a:r>
+              <a:rPr lang="en-US" sz="4600" b="1" dirty="0">
+                <a:solidFill>
+                  <a:srgbClr val="FFFFFF"/>
+                </a:solidFill>
+                <a:latin typeface="Montserrat" pitchFamily="34" charset="0"/>
+                <a:ea typeface="Montserrat" pitchFamily="34" charset="-122"/>
+                <a:cs typeface="Montserrat" pitchFamily="34" charset="-120"/>
+              </a:rPr>
+              <a:t>modèle économique</a:t>
+            </a:r>
+            <a:endParaRPr lang="en-US" sz="4600" dirty="0"/>
+          </a:p>
+        </p:txBody>
+      </p:sp>
+      <p:sp>
+        <p:nvSpPr>
+          <p:cNvPr id="6" name="Shape 3"/>
+          <p:cNvSpPr/>
+          <p:nvPr/>
+        </p:nvSpPr>
+        <p:spPr>
+          <a:xfrm>
+            <a:off x="749808" y="2212848"/>
+            <a:ext cx="640080" cy="45720"/>
+          </a:xfrm>
+          <a:prstGeom prst="rect">
+            <a:avLst/>
+          </a:prstGeom>
+          <a:solidFill>
+            <a:srgbClr val="4D6AB1"/>
+          </a:solidFill>
+          <a:ln/>
+        </p:spPr>
+        <p:txBody>
+          <a:bodyPr/>
+          <a:lstStyle/>
+          <a:p>
+            <a:endParaRPr lang="fr-FR"/>
+          </a:p>
+        </p:txBody>
+      </p:sp>
+      <p:sp>
+        <p:nvSpPr>
+          <p:cNvPr id="7" name="Text 4"/>
+          <p:cNvSpPr/>
+          <p:nvPr/>
+        </p:nvSpPr>
+        <p:spPr>
+          <a:xfrm>
+            <a:off x="731520" y="4572000"/>
+            <a:ext cx="6400800" cy="1005840"/>
+          </a:xfrm>
+          <a:prstGeom prst="rect">
+            <a:avLst/>
+          </a:prstGeom>
+          <a:noFill/>
+          <a:ln/>
+        </p:spPr>
+        <p:txBody>
+          <a:bodyPr wrap="square" lIns="0" tIns="0" rIns="0" bIns="0" rtlCol="0" anchor="ctr"/>
+          <a:lstStyle/>
+          <a:p>
+            <a:pPr marL="0" indent="0">
+              <a:lnSpc>
+                <a:spcPct val="130000"/>
+              </a:lnSpc>
+              <a:buNone/>
+            </a:pPr>
+            <a:r>
+              <a:rPr lang="en-US" sz="1500" dirty="0">
+                <a:solidFill>
+                  <a:srgbClr val="C9CEDA"/>
+                </a:solidFill>
+                <a:latin typeface="Calibri" pitchFamily="34" charset="0"/>
+                <a:ea typeface="Calibri" pitchFamily="34" charset="-122"/>
+                <a:cs typeface="Calibri" pitchFamily="34" charset="-120"/>
+              </a:rPr>
+              <a:t>KWISMO face à l'existant, et le modèle de revenus envisagé aux côtés d'Orange Cameroun.</a:t>
+            </a:r>
+            <a:endParaRPr lang="en-US" sz="1500" dirty="0"/>
+          </a:p>
+        </p:txBody>
+      </p:sp>
+      <p:sp>
+        <p:nvSpPr>
+          <p:cNvPr id="8" name="Shape 5"/>
+          <p:cNvSpPr/>
+          <p:nvPr/>
+        </p:nvSpPr>
+        <p:spPr>
+          <a:xfrm>
+            <a:off x="9144000" y="1463040"/>
+            <a:ext cx="3931920" cy="3931920"/>
+          </a:xfrm>
+          <a:prstGeom prst="ellipse">
+            <a:avLst/>
+          </a:prstGeom>
+          <a:ln w="15875">
+            <a:solidFill>
+              <a:srgbClr val="4D6AB1">
+                <a:alpha val="45000"/>
+              </a:srgbClr>
+            </a:solidFill>
+            <a:prstDash val="solid"/>
+          </a:ln>
+        </p:spPr>
+        <p:txBody>
+          <a:bodyPr/>
+          <a:lstStyle/>
+          <a:p>
+            <a:endParaRPr lang="fr-FR"/>
+          </a:p>
+        </p:txBody>
+      </p:sp>
+      <p:sp>
+        <p:nvSpPr>
+          <p:cNvPr id="9" name="Shape 6"/>
+          <p:cNvSpPr/>
+          <p:nvPr/>
+        </p:nvSpPr>
+        <p:spPr>
+          <a:xfrm>
+            <a:off x="9464040" y="1783080"/>
+            <a:ext cx="3291840" cy="3291840"/>
+          </a:xfrm>
+          <a:prstGeom prst="ellipse">
+            <a:avLst/>
+          </a:prstGeom>
+          <a:solidFill>
+            <a:srgbClr val="4D6AB1">
+              <a:alpha val="15000"/>
+            </a:srgbClr>
+          </a:solidFill>
+          <a:ln w="19050">
+            <a:solidFill>
+              <a:srgbClr val="4D6AB1">
+                <a:alpha val="75000"/>
+              </a:srgbClr>
+            </a:solidFill>
+            <a:prstDash val="solid"/>
+          </a:ln>
+        </p:spPr>
+        <p:txBody>
+          <a:bodyPr/>
+          <a:lstStyle/>
+          <a:p>
+            <a:endParaRPr lang="fr-FR"/>
+          </a:p>
+        </p:txBody>
+      </p:sp>
+      <p:pic>
+        <p:nvPicPr>
+          <p:cNvPr id="10" name="Image 1" descr="/home/claude/work/icons/layers_FFFFFF.png"/>
+          <p:cNvPicPr>
+            <a:picLocks noChangeAspect="1"/>
+          </p:cNvPicPr>
+          <p:nvPr/>
+        </p:nvPicPr>
+        <p:blipFill>
+          <a:blip r:embed="rId4"/>
+          <a:stretch>
+            <a:fillRect/>
+          </a:stretch>
+        </p:blipFill>
+        <p:spPr>
+          <a:xfrm>
+            <a:off x="10254082" y="2573122"/>
+            <a:ext cx="1711757" cy="1711757"/>
+          </a:xfrm>
+          <a:prstGeom prst="rect">
+            <a:avLst/>
+          </a:prstGeom>
+        </p:spPr>
+      </p:pic>
+      <p:sp>
+        <p:nvSpPr>
+          <p:cNvPr id="11" name="Text 7"/>
           <p:cNvSpPr/>
           <p:nvPr/>
         </p:nvSpPr>
@@ -9948,7 +9971,7 @@
                 <a:ea typeface="Calibri" pitchFamily="34" charset="-122"/>
                 <a:cs typeface="Calibri" pitchFamily="34" charset="-120"/>
               </a:rPr>
-              <a:t>P.17</a:t>
+              <a:t>P.16</a:t>
             </a:r>
             <a:endParaRPr lang="en-US" sz="1300" dirty="0"/>
           </a:p>
@@ -10108,7 +10131,7 @@
                 <a:ea typeface="Calibri" pitchFamily="34" charset="-122"/>
                 <a:cs typeface="Calibri" pitchFamily="34" charset="-120"/>
               </a:rPr>
-              <a:t>P.19</a:t>
+              <a:t>P.18</a:t>
             </a:r>
             <a:endParaRPr lang="en-US" sz="1300" dirty="0"/>
           </a:p>
@@ -10268,7 +10291,7 @@
                 <a:ea typeface="Calibri" pitchFamily="34" charset="-122"/>
                 <a:cs typeface="Calibri" pitchFamily="34" charset="-120"/>
               </a:rPr>
-              <a:t>P.20</a:t>
+              <a:t>P.19</a:t>
             </a:r>
             <a:endParaRPr lang="en-US" sz="1300" dirty="0"/>
           </a:p>
@@ -10428,7 +10451,7 @@
                 <a:ea typeface="Calibri" pitchFamily="34" charset="-122"/>
                 <a:cs typeface="Calibri" pitchFamily="34" charset="-120"/>
               </a:rPr>
-              <a:t>P.23</a:t>
+              <a:t>P.22</a:t>
             </a:r>
             <a:endParaRPr lang="en-US" sz="1300" dirty="0"/>
           </a:p>
@@ -10588,7 +10611,7 @@
                 <a:ea typeface="Calibri" pitchFamily="34" charset="-122"/>
                 <a:cs typeface="Calibri" pitchFamily="34" charset="-120"/>
               </a:rPr>
-              <a:t>P.25</a:t>
+              <a:t>P.24</a:t>
             </a:r>
             <a:endParaRPr lang="en-US" sz="1300" dirty="0"/>
           </a:p>
@@ -10642,402 +10665,6 @@
 </file>
 
 <file path=ppt/slides/slide20.xml><?xml version="1.0" encoding="utf-8"?>
-<p:sld xmlns:a="http://schemas.openxmlformats.org/drawingml/2006/main" xmlns:r="http://schemas.openxmlformats.org/officeDocument/2006/relationships" xmlns:p="http://schemas.openxmlformats.org/presentationml/2006/main">
-  <p:cSld name="Slide 17">
-    <p:bg>
-      <p:bgPr>
-        <a:solidFill>
-          <a:srgbClr val="1B2333"/>
-        </a:solidFill>
-        <a:effectLst/>
-      </p:bgPr>
-    </p:bg>
-    <p:spTree>
-      <p:nvGrpSpPr>
-        <p:cNvPr id="1" name=""/>
-        <p:cNvGrpSpPr/>
-        <p:nvPr/>
-      </p:nvGrpSpPr>
-      <p:grpSpPr>
-        <a:xfrm>
-          <a:off x="0" y="0"/>
-          <a:ext cx="0" cy="0"/>
-          <a:chOff x="0" y="0"/>
-          <a:chExt cx="0" cy="0"/>
-        </a:xfrm>
-      </p:grpSpPr>
-      <p:pic>
-        <p:nvPicPr>
-          <p:cNvPr id="2" name="Image 0" descr="/home/claude/work/bg/bg_divider.png"/>
-          <p:cNvPicPr>
-            <a:picLocks noChangeAspect="1"/>
-          </p:cNvPicPr>
-          <p:nvPr/>
-        </p:nvPicPr>
-        <p:blipFill>
-          <a:blip r:embed="rId3"/>
-          <a:stretch>
-            <a:fillRect/>
-          </a:stretch>
-        </p:blipFill>
-        <p:spPr>
-          <a:xfrm>
-            <a:off x="0" y="0"/>
-            <a:ext cx="12191695" cy="6858000"/>
-          </a:xfrm>
-          <a:prstGeom prst="rect">
-            <a:avLst/>
-          </a:prstGeom>
-        </p:spPr>
-      </p:pic>
-      <p:sp>
-        <p:nvSpPr>
-          <p:cNvPr id="3" name="Text 0"/>
-          <p:cNvSpPr/>
-          <p:nvPr/>
-        </p:nvSpPr>
-        <p:spPr>
-          <a:xfrm>
-            <a:off x="731520" y="1051560"/>
-            <a:ext cx="5486400" cy="320040"/>
-          </a:xfrm>
-          <a:prstGeom prst="rect">
-            <a:avLst/>
-          </a:prstGeom>
-          <a:noFill/>
-          <a:ln/>
-        </p:spPr>
-        <p:txBody>
-          <a:bodyPr wrap="square" lIns="0" tIns="0" rIns="0" bIns="0" rtlCol="0" anchor="ctr"/>
-          <a:lstStyle/>
-          <a:p>
-            <a:pPr marL="0" indent="0">
-              <a:buNone/>
-            </a:pPr>
-            <a:r>
-              <a:rPr lang="en-US" sz="1300" b="1" kern="0" spc="200" dirty="0">
-                <a:solidFill>
-                  <a:srgbClr val="4D6AB1"/>
-                </a:solidFill>
-                <a:latin typeface="Calibri" pitchFamily="34" charset="0"/>
-                <a:ea typeface="Calibri" pitchFamily="34" charset="-122"/>
-                <a:cs typeface="Calibri" pitchFamily="34" charset="-120"/>
-              </a:rPr>
-              <a:t>SECTION 07 / 09</a:t>
-            </a:r>
-            <a:endParaRPr lang="en-US" sz="1300" dirty="0"/>
-          </a:p>
-        </p:txBody>
-      </p:sp>
-      <p:sp>
-        <p:nvSpPr>
-          <p:cNvPr id="4" name="Text 1"/>
-          <p:cNvSpPr/>
-          <p:nvPr/>
-        </p:nvSpPr>
-        <p:spPr>
-          <a:xfrm>
-            <a:off x="731520" y="1417320"/>
-            <a:ext cx="6858000" cy="457200"/>
-          </a:xfrm>
-          <a:prstGeom prst="rect">
-            <a:avLst/>
-          </a:prstGeom>
-          <a:noFill/>
-          <a:ln/>
-        </p:spPr>
-        <p:txBody>
-          <a:bodyPr wrap="square" lIns="0" tIns="0" rIns="0" bIns="0" rtlCol="0" anchor="ctr"/>
-          <a:lstStyle/>
-          <a:p>
-            <a:pPr marL="0" indent="0">
-              <a:buNone/>
-            </a:pPr>
-            <a:r>
-              <a:rPr lang="en-US" sz="1500" b="1" kern="0" spc="150" dirty="0">
-                <a:solidFill>
-                  <a:srgbClr val="C9CEDA"/>
-                </a:solidFill>
-                <a:latin typeface="Calibri" pitchFamily="34" charset="0"/>
-                <a:ea typeface="Calibri" pitchFamily="34" charset="-122"/>
-                <a:cs typeface="Calibri" pitchFamily="34" charset="-120"/>
-              </a:rPr>
-              <a:t>SE DIFFÉRENCIER</a:t>
-            </a:r>
-            <a:endParaRPr lang="en-US" sz="1500" dirty="0"/>
-          </a:p>
-        </p:txBody>
-      </p:sp>
-      <p:sp>
-        <p:nvSpPr>
-          <p:cNvPr id="5" name="Text 2"/>
-          <p:cNvSpPr/>
-          <p:nvPr/>
-        </p:nvSpPr>
-        <p:spPr>
-          <a:xfrm>
-            <a:off x="731520" y="2468880"/>
-            <a:ext cx="6949440" cy="1920240"/>
-          </a:xfrm>
-          <a:prstGeom prst="rect">
-            <a:avLst/>
-          </a:prstGeom>
-          <a:noFill/>
-          <a:ln/>
-        </p:spPr>
-        <p:txBody>
-          <a:bodyPr wrap="square" lIns="0" tIns="0" rIns="0" bIns="0" rtlCol="0" anchor="ctr"/>
-          <a:lstStyle/>
-          <a:p>
-            <a:pPr marL="0" indent="0">
-              <a:lnSpc>
-                <a:spcPct val="105000"/>
-              </a:lnSpc>
-              <a:buNone/>
-            </a:pPr>
-            <a:r>
-              <a:rPr lang="en-US" sz="4600" b="1" dirty="0">
-                <a:solidFill>
-                  <a:srgbClr val="FFFFFF"/>
-                </a:solidFill>
-                <a:latin typeface="Montserrat" pitchFamily="34" charset="0"/>
-                <a:ea typeface="Montserrat" pitchFamily="34" charset="-122"/>
-                <a:cs typeface="Montserrat" pitchFamily="34" charset="-120"/>
-              </a:rPr>
-              <a:t>Positionnement &amp;</a:t>
-            </a:r>
-            <a:endParaRPr lang="en-US" sz="4600" dirty="0"/>
-          </a:p>
-          <a:p>
-            <a:pPr marL="0" indent="0">
-              <a:lnSpc>
-                <a:spcPct val="105000"/>
-              </a:lnSpc>
-              <a:buNone/>
-            </a:pPr>
-            <a:r>
-              <a:rPr lang="en-US" sz="4600" b="1" dirty="0">
-                <a:solidFill>
-                  <a:srgbClr val="FFFFFF"/>
-                </a:solidFill>
-                <a:latin typeface="Montserrat" pitchFamily="34" charset="0"/>
-                <a:ea typeface="Montserrat" pitchFamily="34" charset="-122"/>
-                <a:cs typeface="Montserrat" pitchFamily="34" charset="-120"/>
-              </a:rPr>
-              <a:t>modèle économique</a:t>
-            </a:r>
-            <a:endParaRPr lang="en-US" sz="4600" dirty="0"/>
-          </a:p>
-        </p:txBody>
-      </p:sp>
-      <p:sp>
-        <p:nvSpPr>
-          <p:cNvPr id="6" name="Shape 3"/>
-          <p:cNvSpPr/>
-          <p:nvPr/>
-        </p:nvSpPr>
-        <p:spPr>
-          <a:xfrm>
-            <a:off x="749808" y="2212848"/>
-            <a:ext cx="640080" cy="45720"/>
-          </a:xfrm>
-          <a:prstGeom prst="rect">
-            <a:avLst/>
-          </a:prstGeom>
-          <a:solidFill>
-            <a:srgbClr val="4D6AB1"/>
-          </a:solidFill>
-          <a:ln/>
-        </p:spPr>
-        <p:txBody>
-          <a:bodyPr/>
-          <a:lstStyle/>
-          <a:p>
-            <a:endParaRPr lang="fr-FR"/>
-          </a:p>
-        </p:txBody>
-      </p:sp>
-      <p:sp>
-        <p:nvSpPr>
-          <p:cNvPr id="7" name="Text 4"/>
-          <p:cNvSpPr/>
-          <p:nvPr/>
-        </p:nvSpPr>
-        <p:spPr>
-          <a:xfrm>
-            <a:off x="731520" y="4572000"/>
-            <a:ext cx="6400800" cy="1005840"/>
-          </a:xfrm>
-          <a:prstGeom prst="rect">
-            <a:avLst/>
-          </a:prstGeom>
-          <a:noFill/>
-          <a:ln/>
-        </p:spPr>
-        <p:txBody>
-          <a:bodyPr wrap="square" lIns="0" tIns="0" rIns="0" bIns="0" rtlCol="0" anchor="ctr"/>
-          <a:lstStyle/>
-          <a:p>
-            <a:pPr marL="0" indent="0">
-              <a:lnSpc>
-                <a:spcPct val="130000"/>
-              </a:lnSpc>
-              <a:buNone/>
-            </a:pPr>
-            <a:r>
-              <a:rPr lang="en-US" sz="1500" dirty="0">
-                <a:solidFill>
-                  <a:srgbClr val="C9CEDA"/>
-                </a:solidFill>
-                <a:latin typeface="Calibri" pitchFamily="34" charset="0"/>
-                <a:ea typeface="Calibri" pitchFamily="34" charset="-122"/>
-                <a:cs typeface="Calibri" pitchFamily="34" charset="-120"/>
-              </a:rPr>
-              <a:t>KWISMO face à l'existant, et le modèle de revenus envisagé aux côtés d'Orange Cameroun.</a:t>
-            </a:r>
-            <a:endParaRPr lang="en-US" sz="1500" dirty="0"/>
-          </a:p>
-        </p:txBody>
-      </p:sp>
-      <p:sp>
-        <p:nvSpPr>
-          <p:cNvPr id="8" name="Shape 5"/>
-          <p:cNvSpPr/>
-          <p:nvPr/>
-        </p:nvSpPr>
-        <p:spPr>
-          <a:xfrm>
-            <a:off x="9144000" y="1463040"/>
-            <a:ext cx="3931920" cy="3931920"/>
-          </a:xfrm>
-          <a:prstGeom prst="ellipse">
-            <a:avLst/>
-          </a:prstGeom>
-          <a:ln w="15875">
-            <a:solidFill>
-              <a:srgbClr val="4D6AB1">
-                <a:alpha val="45000"/>
-              </a:srgbClr>
-            </a:solidFill>
-            <a:prstDash val="solid"/>
-          </a:ln>
-        </p:spPr>
-        <p:txBody>
-          <a:bodyPr/>
-          <a:lstStyle/>
-          <a:p>
-            <a:endParaRPr lang="fr-FR"/>
-          </a:p>
-        </p:txBody>
-      </p:sp>
-      <p:sp>
-        <p:nvSpPr>
-          <p:cNvPr id="9" name="Shape 6"/>
-          <p:cNvSpPr/>
-          <p:nvPr/>
-        </p:nvSpPr>
-        <p:spPr>
-          <a:xfrm>
-            <a:off x="9464040" y="1783080"/>
-            <a:ext cx="3291840" cy="3291840"/>
-          </a:xfrm>
-          <a:prstGeom prst="ellipse">
-            <a:avLst/>
-          </a:prstGeom>
-          <a:solidFill>
-            <a:srgbClr val="4D6AB1">
-              <a:alpha val="15000"/>
-            </a:srgbClr>
-          </a:solidFill>
-          <a:ln w="19050">
-            <a:solidFill>
-              <a:srgbClr val="4D6AB1">
-                <a:alpha val="75000"/>
-              </a:srgbClr>
-            </a:solidFill>
-            <a:prstDash val="solid"/>
-          </a:ln>
-        </p:spPr>
-        <p:txBody>
-          <a:bodyPr/>
-          <a:lstStyle/>
-          <a:p>
-            <a:endParaRPr lang="fr-FR"/>
-          </a:p>
-        </p:txBody>
-      </p:sp>
-      <p:pic>
-        <p:nvPicPr>
-          <p:cNvPr id="10" name="Image 1" descr="/home/claude/work/icons/layers_FFFFFF.png"/>
-          <p:cNvPicPr>
-            <a:picLocks noChangeAspect="1"/>
-          </p:cNvPicPr>
-          <p:nvPr/>
-        </p:nvPicPr>
-        <p:blipFill>
-          <a:blip r:embed="rId4"/>
-          <a:stretch>
-            <a:fillRect/>
-          </a:stretch>
-        </p:blipFill>
-        <p:spPr>
-          <a:xfrm>
-            <a:off x="10254082" y="2573122"/>
-            <a:ext cx="1711757" cy="1711757"/>
-          </a:xfrm>
-          <a:prstGeom prst="rect">
-            <a:avLst/>
-          </a:prstGeom>
-        </p:spPr>
-      </p:pic>
-      <p:sp>
-        <p:nvSpPr>
-          <p:cNvPr id="11" name="Text 7"/>
-          <p:cNvSpPr/>
-          <p:nvPr/>
-        </p:nvSpPr>
-        <p:spPr>
-          <a:xfrm>
-            <a:off x="11368735" y="6400800"/>
-            <a:ext cx="548640" cy="292608"/>
-          </a:xfrm>
-          <a:prstGeom prst="rect">
-            <a:avLst/>
-          </a:prstGeom>
-          <a:noFill/>
-          <a:ln/>
-        </p:spPr>
-        <p:txBody>
-          <a:bodyPr wrap="square" lIns="0" tIns="0" rIns="0" bIns="0" rtlCol="0" anchor="ctr"/>
-          <a:lstStyle/>
-          <a:p>
-            <a:pPr marL="0" indent="0" algn="r">
-              <a:buNone/>
-            </a:pPr>
-            <a:r>
-              <a:rPr lang="en-US" sz="1100" dirty="0">
-                <a:solidFill>
-                  <a:srgbClr val="8891A3"/>
-                </a:solidFill>
-                <a:latin typeface="Calibri" pitchFamily="34" charset="0"/>
-                <a:ea typeface="Calibri" pitchFamily="34" charset="-122"/>
-                <a:cs typeface="Calibri" pitchFamily="34" charset="-120"/>
-              </a:rPr>
-              <a:t>20</a:t>
-            </a:r>
-            <a:endParaRPr lang="en-US" sz="1100" dirty="0"/>
-          </a:p>
-        </p:txBody>
-      </p:sp>
-    </p:spTree>
-  </p:cSld>
-  <p:clrMapOvr>
-    <a:masterClrMapping/>
-  </p:clrMapOvr>
-</p:sld>
-</file>
-
-<file path=ppt/slides/slide21.xml><?xml version="1.0" encoding="utf-8"?>
 <p:sld xmlns:a="http://schemas.openxmlformats.org/drawingml/2006/main" xmlns:r="http://schemas.openxmlformats.org/officeDocument/2006/relationships" xmlns:p="http://schemas.openxmlformats.org/presentationml/2006/main">
   <p:cSld name="Slide 18">
     <p:bg>
@@ -12346,7 +11973,7 @@
                 <a:ea typeface="Calibri" pitchFamily="34" charset="-122"/>
                 <a:cs typeface="Calibri" pitchFamily="34" charset="-120"/>
               </a:rPr>
-              <a:t>21</a:t>
+              <a:t>20</a:t>
             </a:r>
             <a:endParaRPr lang="en-US" sz="1100" dirty="0"/>
           </a:p>
@@ -12360,7 +11987,7 @@
 </p:sld>
 </file>
 
-<file path=ppt/slides/slide22.xml><?xml version="1.0" encoding="utf-8"?>
+<file path=ppt/slides/slide21.xml><?xml version="1.0" encoding="utf-8"?>
 <p:sld xmlns:a="http://schemas.openxmlformats.org/drawingml/2006/main" xmlns:r="http://schemas.openxmlformats.org/officeDocument/2006/relationships" xmlns:p="http://schemas.openxmlformats.org/presentationml/2006/main" show="0">
   <p:cSld name="Slide 19">
     <p:bg>
@@ -13337,7 +12964,7 @@
                 <a:ea typeface="Calibri" pitchFamily="34" charset="-122"/>
                 <a:cs typeface="Calibri" pitchFamily="34" charset="-120"/>
               </a:rPr>
-              <a:t>22</a:t>
+              <a:t>21</a:t>
             </a:r>
             <a:endParaRPr lang="en-US" sz="1100" dirty="0"/>
           </a:p>
@@ -13351,7 +12978,7 @@
 </p:sld>
 </file>
 
-<file path=ppt/slides/slide23.xml><?xml version="1.0" encoding="utf-8"?>
+<file path=ppt/slides/slide22.xml><?xml version="1.0" encoding="utf-8"?>
 <p:sld xmlns:a="http://schemas.openxmlformats.org/drawingml/2006/main" xmlns:r="http://schemas.openxmlformats.org/officeDocument/2006/relationships" xmlns:p="http://schemas.openxmlformats.org/presentationml/2006/main">
   <p:cSld name="Slide 20">
     <p:bg>
@@ -13713,7 +13340,7 @@
                 <a:ea typeface="Calibri" pitchFamily="34" charset="-122"/>
                 <a:cs typeface="Calibri" pitchFamily="34" charset="-120"/>
               </a:rPr>
-              <a:t>23</a:t>
+              <a:t>22</a:t>
             </a:r>
             <a:endParaRPr lang="en-US" sz="1100" dirty="0"/>
           </a:p>
@@ -13727,7 +13354,7 @@
 </p:sld>
 </file>
 
-<file path=ppt/slides/slide24.xml><?xml version="1.0" encoding="utf-8"?>
+<file path=ppt/slides/slide23.xml><?xml version="1.0" encoding="utf-8"?>
 <p:sld xmlns:a="http://schemas.openxmlformats.org/drawingml/2006/main" xmlns:r="http://schemas.openxmlformats.org/officeDocument/2006/relationships" xmlns:p="http://schemas.openxmlformats.org/presentationml/2006/main">
   <p:cSld name="Slide 21">
     <p:bg>
@@ -15490,7 +15117,7 @@
                 <a:ea typeface="Calibri" pitchFamily="34" charset="-122"/>
                 <a:cs typeface="Calibri" pitchFamily="34" charset="-120"/>
               </a:rPr>
-              <a:t>24</a:t>
+              <a:t>23</a:t>
             </a:r>
             <a:endParaRPr lang="en-US" sz="1100" dirty="0"/>
           </a:p>
@@ -15504,7 +15131,7 @@
 </p:sld>
 </file>
 
-<file path=ppt/slides/slide25.xml><?xml version="1.0" encoding="utf-8"?>
+<file path=ppt/slides/slide24.xml><?xml version="1.0" encoding="utf-8"?>
 <p:sld xmlns:a="http://schemas.openxmlformats.org/drawingml/2006/main" xmlns:r="http://schemas.openxmlformats.org/officeDocument/2006/relationships" xmlns:p="http://schemas.openxmlformats.org/presentationml/2006/main">
   <p:cSld name="Slide 22">
     <p:bg>
@@ -15866,7 +15493,7 @@
                 <a:ea typeface="Calibri" pitchFamily="34" charset="-122"/>
                 <a:cs typeface="Calibri" pitchFamily="34" charset="-120"/>
               </a:rPr>
-              <a:t>25</a:t>
+              <a:t>24</a:t>
             </a:r>
             <a:endParaRPr lang="en-US" sz="1100" dirty="0"/>
           </a:p>
@@ -15880,7 +15507,7 @@
 </p:sld>
 </file>
 
-<file path=ppt/slides/slide26.xml><?xml version="1.0" encoding="utf-8"?>
+<file path=ppt/slides/slide25.xml><?xml version="1.0" encoding="utf-8"?>
 <p:sld xmlns:a="http://schemas.openxmlformats.org/drawingml/2006/main" xmlns:r="http://schemas.openxmlformats.org/officeDocument/2006/relationships" xmlns:p="http://schemas.openxmlformats.org/presentationml/2006/main">
   <p:cSld name="Slide 23">
     <p:bg>
@@ -17862,7 +17489,7 @@
                 <a:ea typeface="Calibri" pitchFamily="34" charset="-122"/>
                 <a:cs typeface="Calibri" pitchFamily="34" charset="-120"/>
               </a:rPr>
-              <a:t>26</a:t>
+              <a:t>25</a:t>
             </a:r>
             <a:endParaRPr lang="en-US" sz="1100" dirty="0"/>
           </a:p>
@@ -17876,7 +17503,7 @@
 </p:sld>
 </file>
 
-<file path=ppt/slides/slide27.xml><?xml version="1.0" encoding="utf-8"?>
+<file path=ppt/slides/slide26.xml><?xml version="1.0" encoding="utf-8"?>
 <p:sld xmlns:a="http://schemas.openxmlformats.org/drawingml/2006/main" xmlns:r="http://schemas.openxmlformats.org/officeDocument/2006/relationships" xmlns:p="http://schemas.openxmlformats.org/presentationml/2006/main">
   <p:cSld name="Slide 24">
     <p:bg>
@@ -18362,7 +17989,7 @@
                 <a:ea typeface="Calibri" pitchFamily="34" charset="-122"/>
                 <a:cs typeface="Calibri" pitchFamily="34" charset="-120"/>
               </a:rPr>
-              <a:t>27</a:t>
+              <a:t>26</a:t>
             </a:r>
             <a:endParaRPr lang="en-US" sz="1100" dirty="0"/>
           </a:p>
@@ -18406,7 +18033,7 @@
 </p:sld>
 </file>
 
-<file path=ppt/slides/slide28.xml><?xml version="1.0" encoding="utf-8"?>
+<file path=ppt/slides/slide27.xml><?xml version="1.0" encoding="utf-8"?>
 <p:sld xmlns:a="http://schemas.openxmlformats.org/drawingml/2006/main" xmlns:r="http://schemas.openxmlformats.org/officeDocument/2006/relationships" xmlns:p="http://schemas.openxmlformats.org/presentationml/2006/main" show="0">
   <p:cSld>
     <p:bg>

</xml_diff>